<commit_message>
Generalize week 13 management seminar and remove attributions
Rewrites the Analytics Words of Wisdom deck as general practitioner
advice in original wording, and generalizes related notes in week 10.

Co-Authored-By: Claude Opus 5.5 <noreply@anthropic.com>
Claude-Session: https://claude.ai/code/session_01XYJ4xmrADRJAP7ufCAYieX
</commit_message>
<xml_diff>
--- a/management-seminars/week10_communicating_findings.pptx
+++ b/management-seminars/week10_communicating_findings.pptx
@@ -576,7 +576,7 @@
           <a:lstStyle/>
           <a:p>
             <a:r>
-              <a:t>An insight is a shift in how someone sees the problem, so it implies change, and change needs persuasion. Exploratory charts help you find things; explanatory charts help others see the one thing that matters. Every estimate has uncertainty that the audience needs in plain terms.</a:t>
+              <a:t>A finding becomes useful when the audience understands what it means for them and what to do next. The charts an analyst uses to search the data are rarely the right ones to present; a presentation chart should make one point obvious. Every estimate has uncertainty that the audience needs in plain terms.</a:t>
             </a:r>
           </a:p>
         </p:txBody>
@@ -1702,7 +1702,7 @@
                   <a:srgbClr val="FFFFFF"/>
                 </a:solidFill>
               </a:rPr>
-              <a:t>Data, narrative and visuals work together</a:t>
+              <a:t>Message: what the audience should know or do</a:t>
             </a:r>
             <a:endParaRPr lang="en-US" sz="2400" dirty="0"/>
           </a:p>
@@ -1720,7 +1720,7 @@
                   <a:srgbClr val="FFFFFF"/>
                 </a:solidFill>
               </a:rPr>
-              <a:t>Explanatory charts vs. exploratory charts</a:t>
+              <a:t>Charts for finding things vs. charts for showing them</a:t>
             </a:r>
             <a:endParaRPr lang="en-US" sz="2400" dirty="0"/>
           </a:p>

</xml_diff>